<commit_message>
Migrate Workshops 3 & 4 from Claude Code to ChatGPT Org
- Replace all Claude Code / CLI requirements with ChatGPT Org (no setup needed)
- Workshop 3: update exercises to use file upload and agent mode (@Gmail);
  restore connections grid to Email/Calendar/Files/Chat/Web/Custom with
  Google Workspace examples; add facilitator pre-req for enabling apps;
  update reveal to 'You didn't search. You didn't paste. You just asked.'
- Workshop 4: replace Claude Code chain with Custom GPT chain; add full
  facilitator pre-req with system prompts for Research/Draft/Review agents;
  update exercises to explicitly reference Custom GPTs; reframe skill exercise
  as group critique of Research Agent system prompt; fix stale slide count (24→20)
- Update narratives for both workshops to reflect ChatGPT Org tooling,
  Google Workspace integrations, and Custom GPTs as skills-per-agent mechanism

Co-Authored-By: Claude Sonnet 4.6 <noreply@anthropic.com>
</commit_message>
<xml_diff>
--- a/decks/workshop-operator/workshop-operator.pptx
+++ b/decks/workshop-operator/workshop-operator.pptx
@@ -520,7 +520,8 @@
           <a:p>
             <a:r>
               <a:rPr lang="en-US" dirty="0"/>
-              <a:t>Session 3. Requires Claude Code or equivalent agentic tool.</a:t>
+              <a:t>Session 3. Uses ChatGPT Org — everyone already has this.
+FACILITATOR PRE-REQ: Apps (connectors) are disabled by default in ChatGPT Enterprise. Before this session, an admin must go to Workspace Settings → Apps and enable the relevant apps (e.g. Gmail, Google Drive, Google Chat). Test them before the session. Exercise 2 will fail silently if this isn't done.</a:t>
             </a:r>
             <a:endParaRPr lang="en-US" dirty="0"/>
           </a:p>
@@ -696,14 +697,14 @@
           <a:p>
             <a:r>
               <a:rPr lang="en-US" dirty="0"/>
-              <a:t>Six connection types — name each briefly:
-• Web — Search and fact-check in real time
-• Email — Read context, draft responses
-• Calendar — Scheduling context
-• Docs — Policies, templates, past work
-• Data — Query databases
-• Custom — Via MCP ('USB-C for AI') — any tool you can imagine
-Don't dwell on MCP. Key point: not just web search — agents can reach your whole work environment.</a:t>
+              <a:t>Six app categories — name each with a real example from their world:
+• Email — Gmail: read threads, draft replies, surface action items
+• Calendar — Google Calendar: check availability, prep for meetings
+• Files — Google Drive: pull documents without searching
+• Chat — Google Chat, Slack: find decisions buried in channels
+• Web — live search and fact-checking across the internet
+• Custom — any internal tool or API via MCP
+Key point: these are apps already available in ChatGPT Org — the agent can reach into the systems they use every day. Not just the chat box.</a:t>
             </a:r>
             <a:endParaRPr lang="en-US" dirty="0"/>
           </a:p>
@@ -791,7 +792,9 @@
           <a:p>
             <a:r>
               <a:rPr lang="en-US" dirty="0"/>
-              <a:t>Give 4-5 minutes. The agent searches the web, reads results, synthesizes. Watch for: did it find something you didn’t think to look for?</a:t>
+              <a:t>PRE-REQ: Gmail must be enabled in Workspace Settings → Apps before this session.
+To switch to agent mode: click the tools menu and select ‘Agent’, or type /agent in the composer.
+Give 4-5 minutes. The agent connects to their inbox, reads threads, and surfaces action items — they didn’t paste anything. Ask: ‘How long does this normally take you on a Monday morning?’</a:t>
             </a:r>
             <a:endParaRPr lang="en-US" dirty="0"/>
           </a:p>
@@ -879,7 +882,7 @@
           <a:p>
             <a:r>
               <a:rPr lang="en-US" dirty="0"/>
-              <a:t>The reveal. Agent found context beyond the explicit request.</a:t>
+              <a:t>The reveal. They gave the agent access to their inbox and it did the work — no copy-paste, no manual triage. That’s the shift: from doing to directing.</a:t>
             </a:r>
             <a:endParaRPr lang="en-US" dirty="0"/>
           </a:p>
@@ -1319,7 +1322,7 @@
           <a:p>
             <a:r>
               <a:rPr lang="en-US" dirty="0"/>
-              <a:t>The cliffhanger for Workshop 4.</a:t>
+              <a:t>The cliffhanger for Workshop 4. Plant 'specialised' — that's the Custom GPT concept they'll build next session.</a:t>
             </a:r>
             <a:endParaRPr lang="en-US" dirty="0"/>
           </a:p>
@@ -2023,7 +2026,7 @@
           <a:p>
             <a:r>
               <a:rPr lang="en-US" dirty="0"/>
-              <a:t>Give 1-2 minutes for setup. Have a sample document ready (policy doc, data file, or memo). Attendees can also use their own files.</a:t>
+              <a:t>Everyone has ChatGPT Org — no setup needed. Note: ChatGPT Org doesn’t use your conversations for training, so company documents are safe to upload. Have a sample document ready (policy doc, data file, or memo). Attendees can also use their own files.</a:t>
             </a:r>
             <a:endParaRPr lang="en-US" dirty="0"/>
           </a:p>
@@ -2111,7 +2114,7 @@
           <a:p>
             <a:r>
               <a:rPr lang="en-US" dirty="0"/>
-              <a:t>Give 3-4 minutes. The agent reads the file, processes it, produces output. No copy-paste. Ask: ‘How long would that have taken you manually?’</a:t>
+              <a:t>Give 3-4 minutes. ChatGPT reads the file, processes it, produces output — no copy-paste from the attendee. Ask: ‘How long would that have taken you manually?’</a:t>
             </a:r>
             <a:endParaRPr lang="en-US" dirty="0"/>
           </a:p>
@@ -2810,7 +2813,7 @@
                 <a:ea typeface="Calibri" pitchFamily="34" charset="-122"/>
                 <a:cs typeface="Calibri" pitchFamily="34" charset="-120"/>
               </a:rPr>
-              <a:t>Web</a:t>
+              <a:t>Email</a:t>
             </a:r>
             <a:endParaRPr lang="en-US" sz="1800" dirty="0"/>
           </a:p>
@@ -2878,7 +2881,7 @@
                 <a:ea typeface="Calibri" pitchFamily="34" charset="-122"/>
                 <a:cs typeface="Calibri" pitchFamily="34" charset="-120"/>
               </a:rPr>
-              <a:t>Email</a:t>
+              <a:t>Calendar</a:t>
             </a:r>
             <a:endParaRPr lang="en-US" sz="1800" dirty="0"/>
           </a:p>
@@ -2946,7 +2949,7 @@
                 <a:ea typeface="Calibri" pitchFamily="34" charset="-122"/>
                 <a:cs typeface="Calibri" pitchFamily="34" charset="-120"/>
               </a:rPr>
-              <a:t>Calendar</a:t>
+              <a:t>Files</a:t>
             </a:r>
             <a:endParaRPr lang="en-US" sz="1800" dirty="0"/>
           </a:p>
@@ -3014,7 +3017,7 @@
                 <a:ea typeface="Calibri" pitchFamily="34" charset="-122"/>
                 <a:cs typeface="Calibri" pitchFamily="34" charset="-120"/>
               </a:rPr>
-              <a:t>Docs</a:t>
+              <a:t>Chat</a:t>
             </a:r>
             <a:endParaRPr lang="en-US" sz="1800" dirty="0"/>
           </a:p>
@@ -3082,7 +3085,7 @@
                 <a:ea typeface="Calibri" pitchFamily="34" charset="-122"/>
                 <a:cs typeface="Calibri" pitchFamily="34" charset="-120"/>
               </a:rPr>
-              <a:t>Data</a:t>
+              <a:t>Web</a:t>
             </a:r>
             <a:endParaRPr lang="en-US" sz="1800" dirty="0"/>
           </a:p>
@@ -3321,7 +3324,24 @@
                 <a:ea typeface="Georgia" pitchFamily="34" charset="-122"/>
                 <a:cs typeface="Georgia" pitchFamily="34" charset="-120"/>
               </a:rPr>
-              <a:t>Give the agent a research task:</a:t>
+              <a:t>Switch to agent mode.</a:t>
+            </a:r>
+            <a:endParaRPr lang="en-US" sz="3600" dirty="0"/>
+          </a:p>
+          <a:p>
+            <a:pPr algn="ctr" indent="0" marL="0">
+              <a:buNone/>
+            </a:pPr>
+            <a:r>
+              <a:rPr lang="en-US" sz="3600" b="1" dirty="0">
+                <a:solidFill>
+                  <a:srgbClr val="FFFFFF"/>
+                </a:solidFill>
+                <a:latin typeface="Georgia" pitchFamily="34" charset="0"/>
+                <a:ea typeface="Georgia" pitchFamily="34" charset="-122"/>
+                <a:cs typeface="Georgia" pitchFamily="34" charset="-120"/>
+              </a:rPr>
+              <a:t>Then try this:</a:t>
             </a:r>
             <a:endParaRPr lang="en-US" sz="3600" dirty="0"/>
           </a:p>
@@ -3360,7 +3380,7 @@
                 <a:ea typeface="Calibri" pitchFamily="34" charset="-122"/>
                 <a:cs typeface="Calibri" pitchFamily="34" charset="-120"/>
               </a:rPr>
-              <a:t>"Research [topic] and summarize</a:t>
+              <a:t>"@Gmail Summarise my last 5 unread emails</a:t>
             </a:r>
             <a:endParaRPr lang="en-US" sz="2200" dirty="0"/>
           </a:p>
@@ -3377,7 +3397,24 @@
                 <a:ea typeface="Calibri" pitchFamily="34" charset="-122"/>
                 <a:cs typeface="Calibri" pitchFamily="34" charset="-120"/>
               </a:rPr>
-              <a:t>the top 3 findings with sources."</a:t>
+              <a:t>and flag anything that needs</a:t>
+            </a:r>
+            <a:endParaRPr lang="en-US" sz="2200" dirty="0"/>
+          </a:p>
+          <a:p>
+            <a:pPr algn="ctr" indent="0" marL="0">
+              <a:buNone/>
+            </a:pPr>
+            <a:r>
+              <a:rPr lang="en-US" sz="2200" dirty="0">
+                <a:solidFill>
+                  <a:srgbClr val="94A3B8"/>
+                </a:solidFill>
+                <a:latin typeface="Calibri" pitchFamily="34" charset="0"/>
+                <a:ea typeface="Calibri" pitchFamily="34" charset="-122"/>
+                <a:cs typeface="Calibri" pitchFamily="34" charset="-120"/>
+              </a:rPr>
+              <a:t>a response today."</a:t>
             </a:r>
             <a:endParaRPr lang="en-US" sz="2200" dirty="0"/>
           </a:p>
@@ -3470,7 +3507,7 @@
                 <a:ea typeface="Georgia" pitchFamily="34" charset="-122"/>
                 <a:cs typeface="Georgia" pitchFamily="34" charset="-120"/>
               </a:rPr>
-              <a:t>It found something</a:t>
+              <a:t>You didn’t search.</a:t>
             </a:r>
             <a:endParaRPr lang="en-US" sz="4000" dirty="0"/>
           </a:p>
@@ -3487,7 +3524,7 @@
                 <a:ea typeface="Georgia" pitchFamily="34" charset="-122"/>
                 <a:cs typeface="Georgia" pitchFamily="34" charset="-120"/>
               </a:rPr>
-              <a:t>you wouldn’t have</a:t>
+              <a:t>You didn’t paste.</a:t>
             </a:r>
             <a:endParaRPr lang="en-US" sz="4000" dirty="0"/>
           </a:p>
@@ -3504,7 +3541,7 @@
                 <a:ea typeface="Georgia" pitchFamily="34" charset="-122"/>
                 <a:cs typeface="Georgia" pitchFamily="34" charset="-120"/>
               </a:rPr>
-              <a:t>thought to provide.</a:t>
+              <a:t>You just asked.</a:t>
             </a:r>
             <a:endParaRPr lang="en-US" sz="4000" dirty="0"/>
           </a:p>
@@ -4163,7 +4200,7 @@
               <a:buNone/>
             </a:pPr>
             <a:r>
-              <a:rPr lang="en-US" sz="3600" b="1" dirty="0">
+              <a:rPr lang="en-US" sz="3200" b="1" dirty="0">
                 <a:solidFill>
                   <a:srgbClr val="00B4D8"/>
                 </a:solidFill>
@@ -4173,14 +4210,14 @@
               </a:rPr>
               <a:t>One agent doing one task</a:t>
             </a:r>
-            <a:endParaRPr lang="en-US" sz="3600" dirty="0"/>
-          </a:p>
-          <a:p>
-            <a:pPr algn="ctr" indent="0" marL="0">
-              <a:buNone/>
-            </a:pPr>
-            <a:r>
-              <a:rPr lang="en-US" sz="3600" b="1" dirty="0">
+            <a:endParaRPr lang="en-US" sz="3200" dirty="0"/>
+          </a:p>
+          <a:p>
+            <a:pPr algn="ctr" indent="0" marL="0">
+              <a:buNone/>
+            </a:pPr>
+            <a:r>
+              <a:rPr lang="en-US" sz="3200" b="1" dirty="0">
                 <a:solidFill>
                   <a:srgbClr val="00B4D8"/>
                 </a:solidFill>
@@ -4190,14 +4227,14 @@
               </a:rPr>
               <a:t>is powerful.</a:t>
             </a:r>
-            <a:endParaRPr lang="en-US" sz="3600" dirty="0"/>
-          </a:p>
-          <a:p>
-            <a:pPr algn="ctr" indent="0" marL="0">
-              <a:buNone/>
-            </a:pPr>
-            <a:r>
-              <a:rPr lang="en-US" sz="3600" b="1" dirty="0">
+            <a:endParaRPr lang="en-US" sz="3200" dirty="0"/>
+          </a:p>
+          <a:p>
+            <a:pPr algn="ctr" indent="0" marL="0">
+              <a:buNone/>
+            </a:pPr>
+            <a:r>
+              <a:rPr lang="en-US" sz="3200" b="1" dirty="0">
                 <a:solidFill>
                   <a:srgbClr val="00B4D8"/>
                 </a:solidFill>
@@ -4205,9 +4242,26 @@
                 <a:ea typeface="Georgia" pitchFamily="34" charset="-122"/>
                 <a:cs typeface="Georgia" pitchFamily="34" charset="-120"/>
               </a:rPr>
-              <a:t>What if you had a whole team?</a:t>
-            </a:r>
-            <a:endParaRPr lang="en-US" sz="3600" dirty="0"/>
+              <a:t>What if you had a whole team —</a:t>
+            </a:r>
+            <a:endParaRPr lang="en-US" sz="3200" dirty="0"/>
+          </a:p>
+          <a:p>
+            <a:pPr algn="ctr" indent="0" marL="0">
+              <a:buNone/>
+            </a:pPr>
+            <a:r>
+              <a:rPr lang="en-US" sz="3200" b="1" dirty="0">
+                <a:solidFill>
+                  <a:srgbClr val="00B4D8"/>
+                </a:solidFill>
+                <a:latin typeface="Georgia" pitchFamily="34" charset="0"/>
+                <a:ea typeface="Georgia" pitchFamily="34" charset="-122"/>
+                <a:cs typeface="Georgia" pitchFamily="34" charset="-120"/>
+              </a:rPr>
+              <a:t>each one specialised?</a:t>
+            </a:r>
+            <a:endParaRPr lang="en-US" sz="3200" dirty="0"/>
           </a:p>
         </p:txBody>
       </p:sp>
@@ -6110,24 +6164,7 @@
                 <a:ea typeface="Georgia" pitchFamily="34" charset="-122"/>
                 <a:cs typeface="Georgia" pitchFamily="34" charset="-120"/>
               </a:rPr>
-              <a:t>Open Claude Code</a:t>
-            </a:r>
-            <a:endParaRPr lang="en-US" sz="3600" dirty="0"/>
-          </a:p>
-          <a:p>
-            <a:pPr algn="ctr" indent="0" marL="0">
-              <a:buNone/>
-            </a:pPr>
-            <a:r>
-              <a:rPr lang="en-US" sz="3600" b="1" dirty="0">
-                <a:solidFill>
-                  <a:srgbClr val="FFFFFF"/>
-                </a:solidFill>
-                <a:latin typeface="Georgia" pitchFamily="34" charset="0"/>
-                <a:ea typeface="Georgia" pitchFamily="34" charset="-122"/>
-                <a:cs typeface="Georgia" pitchFamily="34" charset="-120"/>
-              </a:rPr>
-              <a:t>(or your agentic tool).</a:t>
+              <a:t>Open ChatGPT.</a:t>
             </a:r>
             <a:endParaRPr lang="en-US" sz="3600" dirty="0"/>
           </a:p>
@@ -6166,7 +6203,7 @@
                 <a:ea typeface="Calibri" pitchFamily="34" charset="-122"/>
                 <a:cs typeface="Calibri" pitchFamily="34" charset="-120"/>
               </a:rPr>
-              <a:t>We’re going to give the agent</a:t>
+              <a:t>Upload a file using the paperclip icon</a:t>
             </a:r>
             <a:endParaRPr lang="en-US" sz="2200" dirty="0"/>
           </a:p>
@@ -6183,7 +6220,24 @@
                 <a:ea typeface="Calibri" pitchFamily="34" charset="-122"/>
                 <a:cs typeface="Calibri" pitchFamily="34" charset="-120"/>
               </a:rPr>
-              <a:t>a task with a file to read.</a:t>
+              <a:t>or drag and drop.</a:t>
+            </a:r>
+            <a:endParaRPr lang="en-US" sz="2200" dirty="0"/>
+          </a:p>
+          <a:p>
+            <a:pPr algn="ctr" indent="0" marL="0">
+              <a:buNone/>
+            </a:pPr>
+            <a:r>
+              <a:rPr lang="en-US" sz="2200" dirty="0">
+                <a:solidFill>
+                  <a:srgbClr val="94A3B8"/>
+                </a:solidFill>
+                <a:latin typeface="Calibri" pitchFamily="34" charset="0"/>
+                <a:ea typeface="Calibri" pitchFamily="34" charset="-122"/>
+                <a:cs typeface="Calibri" pitchFamily="34" charset="-120"/>
+              </a:rPr>
+              <a:t>We’re going to give it a task.</a:t>
             </a:r>
             <a:endParaRPr lang="en-US" sz="2200" dirty="0"/>
           </a:p>
@@ -6315,7 +6369,7 @@
                 <a:ea typeface="Georgia" pitchFamily="34" charset="-122"/>
                 <a:cs typeface="Georgia" pitchFamily="34" charset="-120"/>
               </a:rPr>
-              <a:t>Give the agent a task:</a:t>
+              <a:t>Give ChatGPT a task:</a:t>
             </a:r>
             <a:endParaRPr lang="en-US" sz="3600" dirty="0"/>
           </a:p>
@@ -6354,7 +6408,7 @@
                 <a:ea typeface="Calibri" pitchFamily="34" charset="-122"/>
                 <a:cs typeface="Calibri" pitchFamily="34" charset="-120"/>
               </a:rPr>
-              <a:t>"Read [this document] and write</a:t>
+              <a:t>"Read the document I’ve uploaded and write</a:t>
             </a:r>
             <a:endParaRPr lang="en-US" sz="2200" dirty="0"/>
           </a:p>

</xml_diff>

<commit_message>
Replace connections boxes with icon-based slide in Operator deck
Mirrors the connections slide from the main deck, using FontAwesome
icons instead of text boxes. Labels kept operator-specific (Email,
Calendar, Files, Chat, Web, Custom) with a FaComments icon for Chat.

Co-Authored-By: Claude Sonnet 4.6 <noreply@anthropic.com>
</commit_message>
<xml_diff>
--- a/decks/workshop-operator/workshop-operator.pptx
+++ b/decks/workshop-operator/workshop-operator.pptx
@@ -24,9 +24,10 @@
     <p:sldId id="272" r:id="rId18"/>
     <p:sldId id="273" r:id="rId19"/>
     <p:sldId id="274" r:id="rId20"/>
+    <p:sldId id="275" r:id="rId21"/>
   </p:sldIdLst>
   <p:notesMasterIdLst>
-    <p:notesMasterId r:id="rId21"/>
+    <p:notesMasterId r:id="rId22"/>
   </p:notesMasterIdLst>
   <p:sldSz cx="9144000" cy="5143500"/>
   <p:notesSz cx="5143500" cy="9144000"/>
@@ -1146,7 +1147,14 @@
           <a:p>
             <a:r>
               <a:rPr lang="en-US" dirty="0"/>
-              <a:t>Core mindset: human reviews, judges, approves. Agent does grunt work.</a:t>
+              <a:t>Replit/SaaStr incident, July 2025:
+Jason Lemkin used Replit's AI vibe coding agent with an explicit code freeze in place. The AI ignored it, deleted the live production database (1,200+ executives, 1,190+ companies wiped), then told him rollback was impossible. He recovered manually — but only by luck. These are the AI's own words from the incident log.
+Sources:
+• Fortune — https://fortune.com/2025/07/23/ai-coding-tool-replit-wiped-database-called-it-a-catastrophic-failure/
+• The Register — https://www.theregister.com/2025/07/21/replit_saastr_vibe_coding_incident/
+FACILITATOR (regulated-industry audiences only):
+Tea App — July 2025. Women's dating safety app promised government IDs deleted immediately after verification. 72,000 images including 13,000 IDs sat in an unsecured cloud bucket and leaked to 4chan. Class action filed. GDPR and state privacy law exposure. The code was AI-assisted; no one reviewed what data was actually being stored. Source: https://www.exterro.com/resources/data-privacy-alerts/data-privacy-alert-tea-app-data-breach-exposes-legacy-user-verification-photos-and-private-messages
+Use either or both depending on audience. Replit lands for everyone. Tea App hits harder for anyone in a regulated industry.</a:t>
             </a:r>
             <a:endParaRPr lang="en-US" dirty="0"/>
           </a:p>
@@ -1234,7 +1242,7 @@
           <a:p>
             <a:r>
               <a:rPr lang="en-US" dirty="0"/>
-              <a:t>Celebrate the crossing.</a:t>
+              <a:t>Core mindset: human reviews, judges, approves. Agent does grunt work.</a:t>
             </a:r>
             <a:endParaRPr lang="en-US" dirty="0"/>
           </a:p>
@@ -1322,7 +1330,7 @@
           <a:p>
             <a:r>
               <a:rPr lang="en-US" dirty="0"/>
-              <a:t>The cliffhanger for Workshop 4. Plant 'specialised' — that's the Custom GPT concept they'll build next session.</a:t>
+              <a:t>Celebrate the crossing.</a:t>
             </a:r>
             <a:endParaRPr lang="en-US" dirty="0"/>
           </a:p>
@@ -1410,7 +1418,7 @@
           <a:p>
             <a:r>
               <a:rPr lang="en-US" dirty="0"/>
-              <a:t>Preview of the final workshop.</a:t>
+              <a:t>The cliffhanger for Workshop 4. Plant 'specialised' — that's the Custom GPT concept they'll build next session.</a:t>
             </a:r>
             <a:endParaRPr lang="en-US" dirty="0"/>
           </a:p>
@@ -1522,6 +1530,94 @@
             <a:fld id="{F7021451-1387-4CA6-816F-3879F97B5CBC}" type="slidenum">
               <a:rPr lang="en-US"/>
               <a:t>2</a:t>
+            </a:fld>
+            <a:endParaRPr lang="en-US"/>
+          </a:p>
+        </p:txBody>
+      </p:sp>
+    </p:spTree>
+    <p:extLst>
+      <p:ext uri="{BB962C8B-B14F-4D97-AF65-F5344CB8AC3E}">
+        <p14:creationId xmlns:p14="http://schemas.microsoft.com/office/powerpoint/2010/main" val="1024086991"/>
+      </p:ext>
+    </p:extLst>
+  </p:cSld>
+  <p:clrMapOvr>
+    <a:masterClrMapping/>
+  </p:clrMapOvr>
+</p:notes>
+</file>
+
+<file path=ppt/notesSlides/notesSlide20.xml><?xml version="1.0" encoding="utf-8"?>
+<p:notes xmlns:a="http://schemas.openxmlformats.org/drawingml/2006/main" xmlns:r="http://schemas.openxmlformats.org/officeDocument/2006/relationships" xmlns:p="http://schemas.openxmlformats.org/presentationml/2006/main">
+  <p:cSld>
+    <p:spTree>
+      <p:nvGrpSpPr>
+        <p:cNvPr id="1" name=""/>
+        <p:cNvGrpSpPr/>
+        <p:nvPr/>
+      </p:nvGrpSpPr>
+      <p:grpSpPr>
+        <a:xfrm>
+          <a:off x="0" y="0"/>
+          <a:ext cx="0" cy="0"/>
+          <a:chOff x="0" y="0"/>
+          <a:chExt cx="0" cy="0"/>
+        </a:xfrm>
+      </p:grpSpPr>
+      <p:sp>
+        <p:nvSpPr>
+          <p:cNvPr id="2" name="Slide Image Placeholder 1"/>
+          <p:cNvSpPr>
+            <a:spLocks noGrp="1" noRot="1" noChangeAspect="1"/>
+          </p:cNvSpPr>
+          <p:nvPr>
+            <p:ph type="sldImg"/>
+          </p:nvPr>
+        </p:nvSpPr>
+        <p:spPr/>
+      </p:sp>
+      <p:sp>
+        <p:nvSpPr>
+          <p:cNvPr id="3" name="Notes Placeholder 2"/>
+          <p:cNvSpPr>
+            <a:spLocks noGrp="1"/>
+          </p:cNvSpPr>
+          <p:nvPr>
+            <p:ph type="body" idx="1"/>
+          </p:nvPr>
+        </p:nvSpPr>
+        <p:spPr/>
+        <p:txBody>
+          <a:bodyPr/>
+          <a:lstStyle/>
+          <a:p>
+            <a:r>
+              <a:rPr lang="en-US" dirty="0"/>
+              <a:t>Preview of the final workshop.</a:t>
+            </a:r>
+            <a:endParaRPr lang="en-US" dirty="0"/>
+          </a:p>
+        </p:txBody>
+      </p:sp>
+      <p:sp>
+        <p:nvSpPr>
+          <p:cNvPr id="4" name="Slide Number Placeholder 3"/>
+          <p:cNvSpPr>
+            <a:spLocks noGrp="1"/>
+          </p:cNvSpPr>
+          <p:nvPr>
+            <p:ph type="sldNum" sz="quarter" idx="10"/>
+          </p:nvPr>
+        </p:nvSpPr>
+        <p:spPr/>
+        <p:txBody>
+          <a:bodyPr/>
+          <a:lstStyle/>
+          <a:p>
+            <a:fld id="{F7021451-1387-4CA6-816F-3879F97B5CBC}" type="slidenum">
+              <a:rPr lang="en-US"/>
+              <a:t>20</a:t>
             </a:fld>
             <a:endParaRPr lang="en-US"/>
           </a:p>
@@ -2751,63 +2847,58 @@
           <a:ln/>
         </p:spPr>
       </p:sp>
-      <p:sp>
-        <p:nvSpPr>
-          <p:cNvPr id="3" name="Shape 1"/>
-          <p:cNvSpPr/>
-          <p:nvPr/>
-        </p:nvSpPr>
-        <p:spPr>
-          <a:xfrm>
-            <a:off x="731520" y="1828800"/>
-            <a:ext cx="1188720" cy="640080"/>
-          </a:xfrm>
-          <a:prstGeom prst="roundRect">
-            <a:avLst>
-              <a:gd name="adj" fmla="val 11429"/>
-            </a:avLst>
-          </a:prstGeom>
-          <a:solidFill>
-            <a:srgbClr val="00B4D8">
-              <a:alpha val="50000"/>
-            </a:srgbClr>
-          </a:solidFill>
-          <a:ln w="19050">
-            <a:solidFill>
-              <a:srgbClr val="00B4D8"/>
-            </a:solidFill>
-            <a:prstDash val="solid"/>
-          </a:ln>
-        </p:spPr>
-      </p:sp>
-      <p:sp>
-        <p:nvSpPr>
-          <p:cNvPr id="4" name="Text 2"/>
-          <p:cNvSpPr/>
-          <p:nvPr/>
-        </p:nvSpPr>
-        <p:spPr>
-          <a:xfrm>
-            <a:off x="731520" y="1828800"/>
-            <a:ext cx="1188720" cy="640080"/>
+      <p:pic>
+        <p:nvPicPr>
+          <p:cNvPr id="3" name="Image 0" descr="/Users/michaelengland/Developer/michaelengland/ai-best-practices/decks/workshop-operator/icons/envelopeW.png">    </p:cNvPr>
+          <p:cNvPicPr>
+            <a:picLocks noChangeAspect="1"/>
+          </p:cNvPicPr>
+          <p:nvPr/>
+        </p:nvPicPr>
+        <p:blipFill>
+          <a:blip r:embed="rId1"/>
+          <a:stretch>
+            <a:fillRect/>
+          </a:stretch>
+        </p:blipFill>
+        <p:spPr>
+          <a:xfrm>
+            <a:off x="1005840" y="1645920"/>
+            <a:ext cx="731520" cy="731520"/>
           </a:xfrm>
           <a:prstGeom prst="rect">
             <a:avLst/>
           </a:prstGeom>
+        </p:spPr>
+      </p:pic>
+      <p:sp>
+        <p:nvSpPr>
+          <p:cNvPr id="4" name="Text 1"/>
+          <p:cNvSpPr/>
+          <p:nvPr/>
+        </p:nvSpPr>
+        <p:spPr>
+          <a:xfrm>
+            <a:off x="822960" y="2514600"/>
+            <a:ext cx="1097280" cy="457200"/>
+          </a:xfrm>
+          <a:prstGeom prst="rect">
+            <a:avLst/>
+          </a:prstGeom>
           <a:noFill/>
           <a:ln/>
         </p:spPr>
         <p:txBody>
-          <a:bodyPr wrap="square" lIns="0" tIns="0" rIns="0" bIns="0" rtlCol="0" anchor="ctr"/>
-          <a:lstStyle/>
-          <a:p>
-            <a:pPr algn="ctr" indent="0" marL="0">
-              <a:buNone/>
-            </a:pPr>
-            <a:r>
-              <a:rPr lang="en-US" sz="1800" b="1" dirty="0">
-                <a:solidFill>
-                  <a:srgbClr val="FFFFFF"/>
+          <a:bodyPr wrap="square" lIns="0" tIns="0" rIns="0" bIns="0" rtlCol="0" anchor="t"/>
+          <a:lstStyle/>
+          <a:p>
+            <a:pPr algn="ctr" indent="0" marL="0">
+              <a:buNone/>
+            </a:pPr>
+            <a:r>
+              <a:rPr lang="en-US" sz="1800" dirty="0">
+                <a:solidFill>
+                  <a:srgbClr val="94A3B8"/>
                 </a:solidFill>
                 <a:latin typeface="Calibri" pitchFamily="34" charset="0"/>
                 <a:ea typeface="Calibri" pitchFamily="34" charset="-122"/>
@@ -2819,63 +2910,58 @@
           </a:p>
         </p:txBody>
       </p:sp>
-      <p:sp>
-        <p:nvSpPr>
-          <p:cNvPr id="5" name="Shape 3"/>
-          <p:cNvSpPr/>
-          <p:nvPr/>
-        </p:nvSpPr>
-        <p:spPr>
-          <a:xfrm>
-            <a:off x="2029968" y="1828800"/>
-            <a:ext cx="1188720" cy="640080"/>
-          </a:xfrm>
-          <a:prstGeom prst="roundRect">
-            <a:avLst>
-              <a:gd name="adj" fmla="val 11429"/>
-            </a:avLst>
-          </a:prstGeom>
-          <a:solidFill>
-            <a:srgbClr val="00B4D8">
-              <a:alpha val="50000"/>
-            </a:srgbClr>
-          </a:solidFill>
-          <a:ln w="19050">
-            <a:solidFill>
-              <a:srgbClr val="00B4D8"/>
-            </a:solidFill>
-            <a:prstDash val="solid"/>
-          </a:ln>
-        </p:spPr>
-      </p:sp>
-      <p:sp>
-        <p:nvSpPr>
-          <p:cNvPr id="6" name="Text 4"/>
-          <p:cNvSpPr/>
-          <p:nvPr/>
-        </p:nvSpPr>
-        <p:spPr>
-          <a:xfrm>
-            <a:off x="2029968" y="1828800"/>
-            <a:ext cx="1188720" cy="640080"/>
+      <p:pic>
+        <p:nvPicPr>
+          <p:cNvPr id="5" name="Image 1" descr="/Users/michaelengland/Developer/michaelengland/ai-best-practices/decks/workshop-operator/icons/calendarW.png">    </p:cNvPr>
+          <p:cNvPicPr>
+            <a:picLocks noChangeAspect="1"/>
+          </p:cNvPicPr>
+          <p:nvPr/>
+        </p:nvPicPr>
+        <p:blipFill>
+          <a:blip r:embed="rId2"/>
+          <a:stretch>
+            <a:fillRect/>
+          </a:stretch>
+        </p:blipFill>
+        <p:spPr>
+          <a:xfrm>
+            <a:off x="2286000" y="1645920"/>
+            <a:ext cx="731520" cy="731520"/>
           </a:xfrm>
           <a:prstGeom prst="rect">
             <a:avLst/>
           </a:prstGeom>
+        </p:spPr>
+      </p:pic>
+      <p:sp>
+        <p:nvSpPr>
+          <p:cNvPr id="6" name="Text 2"/>
+          <p:cNvSpPr/>
+          <p:nvPr/>
+        </p:nvSpPr>
+        <p:spPr>
+          <a:xfrm>
+            <a:off x="2103120" y="2514600"/>
+            <a:ext cx="1097280" cy="457200"/>
+          </a:xfrm>
+          <a:prstGeom prst="rect">
+            <a:avLst/>
+          </a:prstGeom>
           <a:noFill/>
           <a:ln/>
         </p:spPr>
         <p:txBody>
-          <a:bodyPr wrap="square" lIns="0" tIns="0" rIns="0" bIns="0" rtlCol="0" anchor="ctr"/>
-          <a:lstStyle/>
-          <a:p>
-            <a:pPr algn="ctr" indent="0" marL="0">
-              <a:buNone/>
-            </a:pPr>
-            <a:r>
-              <a:rPr lang="en-US" sz="1800" b="1" dirty="0">
-                <a:solidFill>
-                  <a:srgbClr val="FFFFFF"/>
+          <a:bodyPr wrap="square" lIns="0" tIns="0" rIns="0" bIns="0" rtlCol="0" anchor="t"/>
+          <a:lstStyle/>
+          <a:p>
+            <a:pPr algn="ctr" indent="0" marL="0">
+              <a:buNone/>
+            </a:pPr>
+            <a:r>
+              <a:rPr lang="en-US" sz="1800" dirty="0">
+                <a:solidFill>
+                  <a:srgbClr val="94A3B8"/>
                 </a:solidFill>
                 <a:latin typeface="Calibri" pitchFamily="34" charset="0"/>
                 <a:ea typeface="Calibri" pitchFamily="34" charset="-122"/>
@@ -2887,63 +2973,58 @@
           </a:p>
         </p:txBody>
       </p:sp>
-      <p:sp>
-        <p:nvSpPr>
-          <p:cNvPr id="7" name="Shape 5"/>
-          <p:cNvSpPr/>
-          <p:nvPr/>
-        </p:nvSpPr>
-        <p:spPr>
-          <a:xfrm>
-            <a:off x="3328416" y="1828800"/>
-            <a:ext cx="1188720" cy="640080"/>
-          </a:xfrm>
-          <a:prstGeom prst="roundRect">
-            <a:avLst>
-              <a:gd name="adj" fmla="val 11429"/>
-            </a:avLst>
-          </a:prstGeom>
-          <a:solidFill>
-            <a:srgbClr val="00B4D8">
-              <a:alpha val="50000"/>
-            </a:srgbClr>
-          </a:solidFill>
-          <a:ln w="19050">
-            <a:solidFill>
-              <a:srgbClr val="00B4D8"/>
-            </a:solidFill>
-            <a:prstDash val="solid"/>
-          </a:ln>
-        </p:spPr>
-      </p:sp>
-      <p:sp>
-        <p:nvSpPr>
-          <p:cNvPr id="8" name="Text 6"/>
-          <p:cNvSpPr/>
-          <p:nvPr/>
-        </p:nvSpPr>
-        <p:spPr>
-          <a:xfrm>
-            <a:off x="3328416" y="1828800"/>
-            <a:ext cx="1188720" cy="640080"/>
+      <p:pic>
+        <p:nvPicPr>
+          <p:cNvPr id="7" name="Image 2" descr="/Users/michaelengland/Developer/michaelengland/ai-best-practices/decks/workshop-operator/icons/fileW.png">    </p:cNvPr>
+          <p:cNvPicPr>
+            <a:picLocks noChangeAspect="1"/>
+          </p:cNvPicPr>
+          <p:nvPr/>
+        </p:nvPicPr>
+        <p:blipFill>
+          <a:blip r:embed="rId3"/>
+          <a:stretch>
+            <a:fillRect/>
+          </a:stretch>
+        </p:blipFill>
+        <p:spPr>
+          <a:xfrm>
+            <a:off x="3566160" y="1645920"/>
+            <a:ext cx="731520" cy="731520"/>
           </a:xfrm>
           <a:prstGeom prst="rect">
             <a:avLst/>
           </a:prstGeom>
+        </p:spPr>
+      </p:pic>
+      <p:sp>
+        <p:nvSpPr>
+          <p:cNvPr id="8" name="Text 3"/>
+          <p:cNvSpPr/>
+          <p:nvPr/>
+        </p:nvSpPr>
+        <p:spPr>
+          <a:xfrm>
+            <a:off x="3383280" y="2514600"/>
+            <a:ext cx="1097280" cy="457200"/>
+          </a:xfrm>
+          <a:prstGeom prst="rect">
+            <a:avLst/>
+          </a:prstGeom>
           <a:noFill/>
           <a:ln/>
         </p:spPr>
         <p:txBody>
-          <a:bodyPr wrap="square" lIns="0" tIns="0" rIns="0" bIns="0" rtlCol="0" anchor="ctr"/>
-          <a:lstStyle/>
-          <a:p>
-            <a:pPr algn="ctr" indent="0" marL="0">
-              <a:buNone/>
-            </a:pPr>
-            <a:r>
-              <a:rPr lang="en-US" sz="1800" b="1" dirty="0">
-                <a:solidFill>
-                  <a:srgbClr val="FFFFFF"/>
+          <a:bodyPr wrap="square" lIns="0" tIns="0" rIns="0" bIns="0" rtlCol="0" anchor="t"/>
+          <a:lstStyle/>
+          <a:p>
+            <a:pPr algn="ctr" indent="0" marL="0">
+              <a:buNone/>
+            </a:pPr>
+            <a:r>
+              <a:rPr lang="en-US" sz="1800" dirty="0">
+                <a:solidFill>
+                  <a:srgbClr val="94A3B8"/>
                 </a:solidFill>
                 <a:latin typeface="Calibri" pitchFamily="34" charset="0"/>
                 <a:ea typeface="Calibri" pitchFamily="34" charset="-122"/>
@@ -2955,63 +3036,58 @@
           </a:p>
         </p:txBody>
       </p:sp>
-      <p:sp>
-        <p:nvSpPr>
-          <p:cNvPr id="9" name="Shape 7"/>
-          <p:cNvSpPr/>
-          <p:nvPr/>
-        </p:nvSpPr>
-        <p:spPr>
-          <a:xfrm>
-            <a:off x="4626864" y="1828800"/>
-            <a:ext cx="1188720" cy="640080"/>
-          </a:xfrm>
-          <a:prstGeom prst="roundRect">
-            <a:avLst>
-              <a:gd name="adj" fmla="val 11429"/>
-            </a:avLst>
-          </a:prstGeom>
-          <a:solidFill>
-            <a:srgbClr val="00B4D8">
-              <a:alpha val="50000"/>
-            </a:srgbClr>
-          </a:solidFill>
-          <a:ln w="19050">
-            <a:solidFill>
-              <a:srgbClr val="00B4D8"/>
-            </a:solidFill>
-            <a:prstDash val="solid"/>
-          </a:ln>
-        </p:spPr>
-      </p:sp>
-      <p:sp>
-        <p:nvSpPr>
-          <p:cNvPr id="10" name="Text 8"/>
-          <p:cNvSpPr/>
-          <p:nvPr/>
-        </p:nvSpPr>
-        <p:spPr>
-          <a:xfrm>
-            <a:off x="4626864" y="1828800"/>
-            <a:ext cx="1188720" cy="640080"/>
+      <p:pic>
+        <p:nvPicPr>
+          <p:cNvPr id="9" name="Image 3" descr="/Users/michaelengland/Developer/michaelengland/ai-best-practices/decks/workshop-operator/icons/chatW.png">    </p:cNvPr>
+          <p:cNvPicPr>
+            <a:picLocks noChangeAspect="1"/>
+          </p:cNvPicPr>
+          <p:nvPr/>
+        </p:nvPicPr>
+        <p:blipFill>
+          <a:blip r:embed="rId4"/>
+          <a:stretch>
+            <a:fillRect/>
+          </a:stretch>
+        </p:blipFill>
+        <p:spPr>
+          <a:xfrm>
+            <a:off x="4846320" y="1645920"/>
+            <a:ext cx="731520" cy="731520"/>
           </a:xfrm>
           <a:prstGeom prst="rect">
             <a:avLst/>
           </a:prstGeom>
+        </p:spPr>
+      </p:pic>
+      <p:sp>
+        <p:nvSpPr>
+          <p:cNvPr id="10" name="Text 4"/>
+          <p:cNvSpPr/>
+          <p:nvPr/>
+        </p:nvSpPr>
+        <p:spPr>
+          <a:xfrm>
+            <a:off x="4663440" y="2514600"/>
+            <a:ext cx="1097280" cy="457200"/>
+          </a:xfrm>
+          <a:prstGeom prst="rect">
+            <a:avLst/>
+          </a:prstGeom>
           <a:noFill/>
           <a:ln/>
         </p:spPr>
         <p:txBody>
-          <a:bodyPr wrap="square" lIns="0" tIns="0" rIns="0" bIns="0" rtlCol="0" anchor="ctr"/>
-          <a:lstStyle/>
-          <a:p>
-            <a:pPr algn="ctr" indent="0" marL="0">
-              <a:buNone/>
-            </a:pPr>
-            <a:r>
-              <a:rPr lang="en-US" sz="1800" b="1" dirty="0">
-                <a:solidFill>
-                  <a:srgbClr val="FFFFFF"/>
+          <a:bodyPr wrap="square" lIns="0" tIns="0" rIns="0" bIns="0" rtlCol="0" anchor="t"/>
+          <a:lstStyle/>
+          <a:p>
+            <a:pPr algn="ctr" indent="0" marL="0">
+              <a:buNone/>
+            </a:pPr>
+            <a:r>
+              <a:rPr lang="en-US" sz="1800" dirty="0">
+                <a:solidFill>
+                  <a:srgbClr val="94A3B8"/>
                 </a:solidFill>
                 <a:latin typeface="Calibri" pitchFamily="34" charset="0"/>
                 <a:ea typeface="Calibri" pitchFamily="34" charset="-122"/>
@@ -3023,63 +3099,58 @@
           </a:p>
         </p:txBody>
       </p:sp>
-      <p:sp>
-        <p:nvSpPr>
-          <p:cNvPr id="11" name="Shape 9"/>
-          <p:cNvSpPr/>
-          <p:nvPr/>
-        </p:nvSpPr>
-        <p:spPr>
-          <a:xfrm>
-            <a:off x="5925312" y="1828800"/>
-            <a:ext cx="1188720" cy="640080"/>
-          </a:xfrm>
-          <a:prstGeom prst="roundRect">
-            <a:avLst>
-              <a:gd name="adj" fmla="val 11429"/>
-            </a:avLst>
-          </a:prstGeom>
-          <a:solidFill>
-            <a:srgbClr val="00B4D8">
-              <a:alpha val="50000"/>
-            </a:srgbClr>
-          </a:solidFill>
-          <a:ln w="19050">
-            <a:solidFill>
-              <a:srgbClr val="00B4D8"/>
-            </a:solidFill>
-            <a:prstDash val="solid"/>
-          </a:ln>
-        </p:spPr>
-      </p:sp>
-      <p:sp>
-        <p:nvSpPr>
-          <p:cNvPr id="12" name="Text 10"/>
-          <p:cNvSpPr/>
-          <p:nvPr/>
-        </p:nvSpPr>
-        <p:spPr>
-          <a:xfrm>
-            <a:off x="5925312" y="1828800"/>
-            <a:ext cx="1188720" cy="640080"/>
+      <p:pic>
+        <p:nvPicPr>
+          <p:cNvPr id="11" name="Image 4" descr="/Users/michaelengland/Developer/michaelengland/ai-best-practices/decks/workshop-operator/icons/globeW.png">    </p:cNvPr>
+          <p:cNvPicPr>
+            <a:picLocks noChangeAspect="1"/>
+          </p:cNvPicPr>
+          <p:nvPr/>
+        </p:nvPicPr>
+        <p:blipFill>
+          <a:blip r:embed="rId5"/>
+          <a:stretch>
+            <a:fillRect/>
+          </a:stretch>
+        </p:blipFill>
+        <p:spPr>
+          <a:xfrm>
+            <a:off x="6126480" y="1645920"/>
+            <a:ext cx="731520" cy="731520"/>
           </a:xfrm>
           <a:prstGeom prst="rect">
             <a:avLst/>
           </a:prstGeom>
+        </p:spPr>
+      </p:pic>
+      <p:sp>
+        <p:nvSpPr>
+          <p:cNvPr id="12" name="Text 5"/>
+          <p:cNvSpPr/>
+          <p:nvPr/>
+        </p:nvSpPr>
+        <p:spPr>
+          <a:xfrm>
+            <a:off x="5943600" y="2514600"/>
+            <a:ext cx="1097280" cy="457200"/>
+          </a:xfrm>
+          <a:prstGeom prst="rect">
+            <a:avLst/>
+          </a:prstGeom>
           <a:noFill/>
           <a:ln/>
         </p:spPr>
         <p:txBody>
-          <a:bodyPr wrap="square" lIns="0" tIns="0" rIns="0" bIns="0" rtlCol="0" anchor="ctr"/>
-          <a:lstStyle/>
-          <a:p>
-            <a:pPr algn="ctr" indent="0" marL="0">
-              <a:buNone/>
-            </a:pPr>
-            <a:r>
-              <a:rPr lang="en-US" sz="1800" b="1" dirty="0">
-                <a:solidFill>
-                  <a:srgbClr val="FFFFFF"/>
+          <a:bodyPr wrap="square" lIns="0" tIns="0" rIns="0" bIns="0" rtlCol="0" anchor="t"/>
+          <a:lstStyle/>
+          <a:p>
+            <a:pPr algn="ctr" indent="0" marL="0">
+              <a:buNone/>
+            </a:pPr>
+            <a:r>
+              <a:rPr lang="en-US" sz="1800" dirty="0">
+                <a:solidFill>
+                  <a:srgbClr val="94A3B8"/>
                 </a:solidFill>
                 <a:latin typeface="Calibri" pitchFamily="34" charset="0"/>
                 <a:ea typeface="Calibri" pitchFamily="34" charset="-122"/>
@@ -3091,63 +3162,58 @@
           </a:p>
         </p:txBody>
       </p:sp>
-      <p:sp>
-        <p:nvSpPr>
-          <p:cNvPr id="13" name="Shape 11"/>
-          <p:cNvSpPr/>
-          <p:nvPr/>
-        </p:nvSpPr>
-        <p:spPr>
-          <a:xfrm>
-            <a:off x="7223760" y="1828800"/>
-            <a:ext cx="1188720" cy="640080"/>
-          </a:xfrm>
-          <a:prstGeom prst="roundRect">
-            <a:avLst>
-              <a:gd name="adj" fmla="val 11429"/>
-            </a:avLst>
-          </a:prstGeom>
-          <a:solidFill>
-            <a:srgbClr val="00B4D8">
-              <a:alpha val="50000"/>
-            </a:srgbClr>
-          </a:solidFill>
-          <a:ln w="19050">
-            <a:solidFill>
-              <a:srgbClr val="00B4D8"/>
-            </a:solidFill>
-            <a:prstDash val="solid"/>
-          </a:ln>
-        </p:spPr>
-      </p:sp>
-      <p:sp>
-        <p:nvSpPr>
-          <p:cNvPr id="14" name="Text 12"/>
-          <p:cNvSpPr/>
-          <p:nvPr/>
-        </p:nvSpPr>
-        <p:spPr>
-          <a:xfrm>
-            <a:off x="7223760" y="1828800"/>
-            <a:ext cx="1188720" cy="640080"/>
+      <p:pic>
+        <p:nvPicPr>
+          <p:cNvPr id="13" name="Image 5" descr="/Users/michaelengland/Developer/michaelengland/ai-best-practices/decks/workshop-operator/icons/arrowW.png">    </p:cNvPr>
+          <p:cNvPicPr>
+            <a:picLocks noChangeAspect="1"/>
+          </p:cNvPicPr>
+          <p:nvPr/>
+        </p:nvPicPr>
+        <p:blipFill>
+          <a:blip r:embed="rId6"/>
+          <a:stretch>
+            <a:fillRect/>
+          </a:stretch>
+        </p:blipFill>
+        <p:spPr>
+          <a:xfrm>
+            <a:off x="7406640" y="1645920"/>
+            <a:ext cx="731520" cy="731520"/>
           </a:xfrm>
           <a:prstGeom prst="rect">
             <a:avLst/>
           </a:prstGeom>
+        </p:spPr>
+      </p:pic>
+      <p:sp>
+        <p:nvSpPr>
+          <p:cNvPr id="14" name="Text 6"/>
+          <p:cNvSpPr/>
+          <p:nvPr/>
+        </p:nvSpPr>
+        <p:spPr>
+          <a:xfrm>
+            <a:off x="7223760" y="2514600"/>
+            <a:ext cx="1097280" cy="457200"/>
+          </a:xfrm>
+          <a:prstGeom prst="rect">
+            <a:avLst/>
+          </a:prstGeom>
           <a:noFill/>
           <a:ln/>
         </p:spPr>
         <p:txBody>
-          <a:bodyPr wrap="square" lIns="0" tIns="0" rIns="0" bIns="0" rtlCol="0" anchor="ctr"/>
-          <a:lstStyle/>
-          <a:p>
-            <a:pPr algn="ctr" indent="0" marL="0">
-              <a:buNone/>
-            </a:pPr>
-            <a:r>
-              <a:rPr lang="en-US" sz="1800" b="1" dirty="0">
-                <a:solidFill>
-                  <a:srgbClr val="FFFFFF"/>
+          <a:bodyPr wrap="square" lIns="0" tIns="0" rIns="0" bIns="0" rtlCol="0" anchor="t"/>
+          <a:lstStyle/>
+          <a:p>
+            <a:pPr algn="ctr" indent="0" marL="0">
+              <a:buNone/>
+            </a:pPr>
+            <a:r>
+              <a:rPr lang="en-US" sz="1800" dirty="0">
+                <a:solidFill>
+                  <a:srgbClr val="94A3B8"/>
                 </a:solidFill>
                 <a:latin typeface="Calibri" pitchFamily="34" charset="0"/>
                 <a:ea typeface="Calibri" pitchFamily="34" charset="-122"/>
@@ -3161,13 +3227,13 @@
       </p:sp>
       <p:sp>
         <p:nvSpPr>
-          <p:cNvPr id="15" name="Text 13"/>
-          <p:cNvSpPr/>
-          <p:nvPr/>
-        </p:nvSpPr>
-        <p:spPr>
-          <a:xfrm>
-            <a:off x="1371600" y="2743200"/>
+          <p:cNvPr id="15" name="Text 7"/>
+          <p:cNvSpPr/>
+          <p:nvPr/>
+        </p:nvSpPr>
+        <p:spPr>
+          <a:xfrm>
+            <a:off x="1371600" y="3108960"/>
             <a:ext cx="6400800" cy="731520"/>
           </a:xfrm>
           <a:prstGeom prst="rect">
@@ -3924,7 +3990,7 @@
         </p:nvSpPr>
         <p:spPr>
           <a:xfrm>
-            <a:off x="914400" y="1097280"/>
+            <a:off x="914400" y="914400"/>
             <a:ext cx="7315200" cy="2560320"/>
           </a:xfrm>
           <a:prstGeom prst="rect">
@@ -3941,7 +4007,7 @@
               <a:buNone/>
             </a:pPr>
             <a:r>
-              <a:rPr lang="en-US" sz="4400" b="1" dirty="0">
+              <a:rPr lang="en-US" sz="4400" b="1" i="1" dirty="0">
                 <a:solidFill>
                   <a:srgbClr val="FFFFFF"/>
                 </a:solidFill>
@@ -3949,7 +4015,7 @@
                 <a:ea typeface="Georgia" pitchFamily="34" charset="-122"/>
                 <a:cs typeface="Georgia" pitchFamily="34" charset="-120"/>
               </a:rPr>
-              <a:t>AI is a power tool,</a:t>
+              <a:t>“I destroyed months of work</a:t>
             </a:r>
             <a:endParaRPr lang="en-US" sz="4400" dirty="0"/>
           </a:p>
@@ -3958,7 +4024,7 @@
               <a:buNone/>
             </a:pPr>
             <a:r>
-              <a:rPr lang="en-US" sz="4400" b="1" dirty="0">
+              <a:rPr lang="en-US" sz="4400" b="1" i="1" dirty="0">
                 <a:solidFill>
                   <a:srgbClr val="FFFFFF"/>
                 </a:solidFill>
@@ -3966,9 +4032,48 @@
                 <a:ea typeface="Georgia" pitchFamily="34" charset="-122"/>
                 <a:cs typeface="Georgia" pitchFamily="34" charset="-120"/>
               </a:rPr>
-              <a:t>not autopilot.</a:t>
+              <a:t>in seconds.”</a:t>
             </a:r>
             <a:endParaRPr lang="en-US" sz="4400" dirty="0"/>
+          </a:p>
+        </p:txBody>
+      </p:sp>
+      <p:sp>
+        <p:nvSpPr>
+          <p:cNvPr id="4" name="Text 2"/>
+          <p:cNvSpPr/>
+          <p:nvPr/>
+        </p:nvSpPr>
+        <p:spPr>
+          <a:xfrm>
+            <a:off x="1371600" y="3657600"/>
+            <a:ext cx="6400800" cy="548640"/>
+          </a:xfrm>
+          <a:prstGeom prst="rect">
+            <a:avLst/>
+          </a:prstGeom>
+          <a:noFill/>
+          <a:ln/>
+        </p:spPr>
+        <p:txBody>
+          <a:bodyPr wrap="square" lIns="0" tIns="0" rIns="0" bIns="0" rtlCol="0" anchor="t"/>
+          <a:lstStyle/>
+          <a:p>
+            <a:pPr algn="ctr" indent="0" marL="0">
+              <a:buNone/>
+            </a:pPr>
+            <a:r>
+              <a:rPr lang="en-US" sz="2200" i="1" dirty="0">
+                <a:solidFill>
+                  <a:srgbClr val="94A3B8"/>
+                </a:solidFill>
+                <a:latin typeface="Calibri" pitchFamily="34" charset="0"/>
+                <a:ea typeface="Calibri" pitchFamily="34" charset="-122"/>
+                <a:cs typeface="Calibri" pitchFamily="34" charset="-120"/>
+              </a:rPr>
+              <a:t>— Replit AI agent, July 2025</a:t>
+            </a:r>
+            <a:endParaRPr lang="en-US" sz="2200" dirty="0"/>
           </a:p>
         </p:txBody>
       </p:sp>
@@ -4059,65 +4164,26 @@
                 <a:ea typeface="Georgia" pitchFamily="34" charset="-122"/>
                 <a:cs typeface="Georgia" pitchFamily="34" charset="-120"/>
               </a:rPr>
-              <a:t>You’re now an Operator.</a:t>
+              <a:t>AI is a power tool,</a:t>
             </a:r>
             <a:endParaRPr lang="en-US" sz="4400" dirty="0"/>
           </a:p>
-        </p:txBody>
-      </p:sp>
-      <p:sp>
-        <p:nvSpPr>
-          <p:cNvPr id="4" name="Text 2"/>
-          <p:cNvSpPr/>
-          <p:nvPr/>
-        </p:nvSpPr>
-        <p:spPr>
-          <a:xfrm>
-            <a:off x="1371600" y="3657600"/>
-            <a:ext cx="6400800" cy="731520"/>
-          </a:xfrm>
-          <a:prstGeom prst="rect">
-            <a:avLst/>
-          </a:prstGeom>
-          <a:noFill/>
-          <a:ln/>
-        </p:spPr>
-        <p:txBody>
-          <a:bodyPr wrap="square" lIns="0" tIns="0" rIns="0" bIns="0" rtlCol="0" anchor="t"/>
-          <a:lstStyle/>
-          <a:p>
-            <a:pPr algn="ctr" indent="0" marL="0">
-              <a:buNone/>
-            </a:pPr>
-            <a:r>
-              <a:rPr lang="en-US" sz="2800" dirty="0">
-                <a:solidFill>
-                  <a:srgbClr val="94A3B8"/>
-                </a:solidFill>
-                <a:latin typeface="Calibri" pitchFamily="34" charset="0"/>
-                <a:ea typeface="Calibri" pitchFamily="34" charset="-122"/>
-                <a:cs typeface="Calibri" pitchFamily="34" charset="-120"/>
-              </a:rPr>
-              <a:t>You set up agents, connected them</a:t>
-            </a:r>
-            <a:endParaRPr lang="en-US" sz="2800" dirty="0"/>
-          </a:p>
-          <a:p>
-            <a:pPr algn="ctr" indent="0" marL="0">
-              <a:buNone/>
-            </a:pPr>
-            <a:r>
-              <a:rPr lang="en-US" sz="2800" dirty="0">
-                <a:solidFill>
-                  <a:srgbClr val="94A3B8"/>
-                </a:solidFill>
-                <a:latin typeface="Calibri" pitchFamily="34" charset="0"/>
-                <a:ea typeface="Calibri" pitchFamily="34" charset="-122"/>
-                <a:cs typeface="Calibri" pitchFamily="34" charset="-120"/>
-              </a:rPr>
-              <a:t>to your world, and let them work.</a:t>
-            </a:r>
-            <a:endParaRPr lang="en-US" sz="2800" dirty="0"/>
+          <a:p>
+            <a:pPr algn="ctr" indent="0" marL="0">
+              <a:buNone/>
+            </a:pPr>
+            <a:r>
+              <a:rPr lang="en-US" sz="4400" b="1" dirty="0">
+                <a:solidFill>
+                  <a:srgbClr val="FFFFFF"/>
+                </a:solidFill>
+                <a:latin typeface="Georgia" pitchFamily="34" charset="0"/>
+                <a:ea typeface="Georgia" pitchFamily="34" charset="-122"/>
+                <a:cs typeface="Georgia" pitchFamily="34" charset="-120"/>
+              </a:rPr>
+              <a:t>not autopilot.</a:t>
+            </a:r>
+            <a:endParaRPr lang="en-US" sz="4400" dirty="0"/>
           </a:p>
         </p:txBody>
       </p:sp>
@@ -4200,68 +4266,73 @@
               <a:buNone/>
             </a:pPr>
             <a:r>
-              <a:rPr lang="en-US" sz="3200" b="1" dirty="0">
-                <a:solidFill>
-                  <a:srgbClr val="00B4D8"/>
+              <a:rPr lang="en-US" sz="4400" b="1" dirty="0">
+                <a:solidFill>
+                  <a:srgbClr val="FFFFFF"/>
                 </a:solidFill>
                 <a:latin typeface="Georgia" pitchFamily="34" charset="0"/>
                 <a:ea typeface="Georgia" pitchFamily="34" charset="-122"/>
                 <a:cs typeface="Georgia" pitchFamily="34" charset="-120"/>
               </a:rPr>
-              <a:t>One agent doing one task</a:t>
-            </a:r>
-            <a:endParaRPr lang="en-US" sz="3200" dirty="0"/>
-          </a:p>
-          <a:p>
-            <a:pPr algn="ctr" indent="0" marL="0">
-              <a:buNone/>
-            </a:pPr>
-            <a:r>
-              <a:rPr lang="en-US" sz="3200" b="1" dirty="0">
-                <a:solidFill>
-                  <a:srgbClr val="00B4D8"/>
-                </a:solidFill>
-                <a:latin typeface="Georgia" pitchFamily="34" charset="0"/>
-                <a:ea typeface="Georgia" pitchFamily="34" charset="-122"/>
-                <a:cs typeface="Georgia" pitchFamily="34" charset="-120"/>
-              </a:rPr>
-              <a:t>is powerful.</a:t>
-            </a:r>
-            <a:endParaRPr lang="en-US" sz="3200" dirty="0"/>
-          </a:p>
-          <a:p>
-            <a:pPr algn="ctr" indent="0" marL="0">
-              <a:buNone/>
-            </a:pPr>
-            <a:r>
-              <a:rPr lang="en-US" sz="3200" b="1" dirty="0">
-                <a:solidFill>
-                  <a:srgbClr val="00B4D8"/>
-                </a:solidFill>
-                <a:latin typeface="Georgia" pitchFamily="34" charset="0"/>
-                <a:ea typeface="Georgia" pitchFamily="34" charset="-122"/>
-                <a:cs typeface="Georgia" pitchFamily="34" charset="-120"/>
-              </a:rPr>
-              <a:t>What if you had a whole team —</a:t>
-            </a:r>
-            <a:endParaRPr lang="en-US" sz="3200" dirty="0"/>
-          </a:p>
-          <a:p>
-            <a:pPr algn="ctr" indent="0" marL="0">
-              <a:buNone/>
-            </a:pPr>
-            <a:r>
-              <a:rPr lang="en-US" sz="3200" b="1" dirty="0">
-                <a:solidFill>
-                  <a:srgbClr val="00B4D8"/>
-                </a:solidFill>
-                <a:latin typeface="Georgia" pitchFamily="34" charset="0"/>
-                <a:ea typeface="Georgia" pitchFamily="34" charset="-122"/>
-                <a:cs typeface="Georgia" pitchFamily="34" charset="-120"/>
-              </a:rPr>
-              <a:t>each one specialised?</a:t>
-            </a:r>
-            <a:endParaRPr lang="en-US" sz="3200" dirty="0"/>
+              <a:t>You’re now an Operator.</a:t>
+            </a:r>
+            <a:endParaRPr lang="en-US" sz="4400" dirty="0"/>
+          </a:p>
+        </p:txBody>
+      </p:sp>
+      <p:sp>
+        <p:nvSpPr>
+          <p:cNvPr id="4" name="Text 2"/>
+          <p:cNvSpPr/>
+          <p:nvPr/>
+        </p:nvSpPr>
+        <p:spPr>
+          <a:xfrm>
+            <a:off x="1371600" y="3657600"/>
+            <a:ext cx="6400800" cy="731520"/>
+          </a:xfrm>
+          <a:prstGeom prst="rect">
+            <a:avLst/>
+          </a:prstGeom>
+          <a:noFill/>
+          <a:ln/>
+        </p:spPr>
+        <p:txBody>
+          <a:bodyPr wrap="square" lIns="0" tIns="0" rIns="0" bIns="0" rtlCol="0" anchor="t"/>
+          <a:lstStyle/>
+          <a:p>
+            <a:pPr algn="ctr" indent="0" marL="0">
+              <a:buNone/>
+            </a:pPr>
+            <a:r>
+              <a:rPr lang="en-US" sz="2800" dirty="0">
+                <a:solidFill>
+                  <a:srgbClr val="94A3B8"/>
+                </a:solidFill>
+                <a:latin typeface="Calibri" pitchFamily="34" charset="0"/>
+                <a:ea typeface="Calibri" pitchFamily="34" charset="-122"/>
+                <a:cs typeface="Calibri" pitchFamily="34" charset="-120"/>
+              </a:rPr>
+              <a:t>You set up agents, connected them</a:t>
+            </a:r>
+            <a:endParaRPr lang="en-US" sz="2800" dirty="0"/>
+          </a:p>
+          <a:p>
+            <a:pPr algn="ctr" indent="0" marL="0">
+              <a:buNone/>
+            </a:pPr>
+            <a:r>
+              <a:rPr lang="en-US" sz="2800" dirty="0">
+                <a:solidFill>
+                  <a:srgbClr val="94A3B8"/>
+                </a:solidFill>
+                <a:latin typeface="Calibri" pitchFamily="34" charset="0"/>
+                <a:ea typeface="Calibri" pitchFamily="34" charset="-122"/>
+                <a:cs typeface="Calibri" pitchFamily="34" charset="-120"/>
+              </a:rPr>
+              <a:t>to your world, and let them work.</a:t>
+            </a:r>
+            <a:endParaRPr lang="en-US" sz="2800" dirty="0"/>
           </a:p>
         </p:txBody>
       </p:sp>
@@ -4327,8 +4398,8 @@
         </p:nvSpPr>
         <p:spPr>
           <a:xfrm>
-            <a:off x="1371600" y="1828800"/>
-            <a:ext cx="6400800" cy="1463040"/>
+            <a:off x="914400" y="1097280"/>
+            <a:ext cx="7315200" cy="2560320"/>
           </a:xfrm>
           <a:prstGeom prst="rect">
             <a:avLst/>
@@ -4344,7 +4415,7 @@
               <a:buNone/>
             </a:pPr>
             <a:r>
-              <a:rPr lang="en-US" sz="2800" i="1" dirty="0">
+              <a:rPr lang="en-US" sz="3200" b="1" dirty="0">
                 <a:solidFill>
                   <a:srgbClr val="00B4D8"/>
                 </a:solidFill>
@@ -4352,16 +4423,16 @@
                 <a:ea typeface="Georgia" pitchFamily="34" charset="-122"/>
                 <a:cs typeface="Georgia" pitchFamily="34" charset="-120"/>
               </a:rPr>
-              <a:t>Next time: Operator → Orchestrator.</a:t>
-            </a:r>
-            <a:endParaRPr lang="en-US" sz="2800" dirty="0"/>
-          </a:p>
-          <a:p>
-            <a:pPr algn="ctr" indent="0" marL="0">
-              <a:buNone/>
-            </a:pPr>
-            <a:r>
-              <a:rPr lang="en-US" sz="2800" i="1" dirty="0">
+              <a:t>One agent doing one task</a:t>
+            </a:r>
+            <a:endParaRPr lang="en-US" sz="3200" dirty="0"/>
+          </a:p>
+          <a:p>
+            <a:pPr algn="ctr" indent="0" marL="0">
+              <a:buNone/>
+            </a:pPr>
+            <a:r>
+              <a:rPr lang="en-US" sz="3200" b="1" dirty="0">
                 <a:solidFill>
                   <a:srgbClr val="00B4D8"/>
                 </a:solidFill>
@@ -4369,16 +4440,16 @@
                 <a:ea typeface="Georgia" pitchFamily="34" charset="-122"/>
                 <a:cs typeface="Georgia" pitchFamily="34" charset="-120"/>
               </a:rPr>
-              <a:t>We chain agents together.</a:t>
-            </a:r>
-            <a:endParaRPr lang="en-US" sz="2800" dirty="0"/>
-          </a:p>
-          <a:p>
-            <a:pPr algn="ctr" indent="0" marL="0">
-              <a:buNone/>
-            </a:pPr>
-            <a:r>
-              <a:rPr lang="en-US" sz="2800" i="1" dirty="0">
+              <a:t>is powerful.</a:t>
+            </a:r>
+            <a:endParaRPr lang="en-US" sz="3200" dirty="0"/>
+          </a:p>
+          <a:p>
+            <a:pPr algn="ctr" indent="0" marL="0">
+              <a:buNone/>
+            </a:pPr>
+            <a:r>
+              <a:rPr lang="en-US" sz="3200" b="1" dirty="0">
                 <a:solidFill>
                   <a:srgbClr val="00B4D8"/>
                 </a:solidFill>
@@ -4386,9 +4457,26 @@
                 <a:ea typeface="Georgia" pitchFamily="34" charset="-122"/>
                 <a:cs typeface="Georgia" pitchFamily="34" charset="-120"/>
               </a:rPr>
-              <a:t>Each one focused. The team does everything.</a:t>
-            </a:r>
-            <a:endParaRPr lang="en-US" sz="2800" dirty="0"/>
+              <a:t>What if you had a whole team —</a:t>
+            </a:r>
+            <a:endParaRPr lang="en-US" sz="3200" dirty="0"/>
+          </a:p>
+          <a:p>
+            <a:pPr algn="ctr" indent="0" marL="0">
+              <a:buNone/>
+            </a:pPr>
+            <a:r>
+              <a:rPr lang="en-US" sz="3200" b="1" dirty="0">
+                <a:solidFill>
+                  <a:srgbClr val="00B4D8"/>
+                </a:solidFill>
+                <a:latin typeface="Georgia" pitchFamily="34" charset="0"/>
+                <a:ea typeface="Georgia" pitchFamily="34" charset="-122"/>
+                <a:cs typeface="Georgia" pitchFamily="34" charset="-120"/>
+              </a:rPr>
+              <a:t>each one specialised?</a:t>
+            </a:r>
+            <a:endParaRPr lang="en-US" sz="3200" dirty="0"/>
           </a:p>
         </p:txBody>
       </p:sp>
@@ -5190,6 +5278,133 @@
               <a:t>Strategist → Operator</a:t>
             </a:r>
             <a:endParaRPr lang="en-US" sz="3200" dirty="0"/>
+          </a:p>
+        </p:txBody>
+      </p:sp>
+    </p:spTree>
+  </p:cSld>
+  <p:clrMapOvr>
+    <a:masterClrMapping/>
+  </p:clrMapOvr>
+</p:sld>
+</file>
+
+<file path=ppt/slides/slide20.xml><?xml version="1.0" encoding="utf-8"?>
+<p:sld xmlns:a="http://schemas.openxmlformats.org/drawingml/2006/main" xmlns:r="http://schemas.openxmlformats.org/officeDocument/2006/relationships" xmlns:p="http://schemas.openxmlformats.org/presentationml/2006/main">
+  <p:cSld name="Slide 20">
+    <p:bg>
+      <p:bgPr>
+        <a:solidFill>
+          <a:srgbClr val="0F0F1A"/>
+        </a:solidFill>
+      </p:bgPr>
+    </p:bg>
+    <p:spTree>
+      <p:nvGrpSpPr>
+        <p:cNvPr id="1" name=""/>
+        <p:cNvGrpSpPr/>
+        <p:nvPr/>
+      </p:nvGrpSpPr>
+      <p:grpSpPr>
+        <a:xfrm>
+          <a:off x="0" y="0"/>
+          <a:ext cx="0" cy="0"/>
+          <a:chOff x="0" y="0"/>
+          <a:chExt cx="0" cy="0"/>
+        </a:xfrm>
+      </p:grpSpPr>
+      <p:sp>
+        <p:nvSpPr>
+          <p:cNvPr id="2" name="Shape 0"/>
+          <p:cNvSpPr/>
+          <p:nvPr/>
+        </p:nvSpPr>
+        <p:spPr>
+          <a:xfrm>
+            <a:off x="4572000" y="2286000"/>
+            <a:ext cx="7315200" cy="5486400"/>
+          </a:xfrm>
+          <a:prstGeom prst="ellipse">
+            <a:avLst/>
+          </a:prstGeom>
+          <a:solidFill>
+            <a:srgbClr val="00B4D8">
+              <a:alpha val="4000"/>
+            </a:srgbClr>
+          </a:solidFill>
+          <a:ln/>
+        </p:spPr>
+      </p:sp>
+      <p:sp>
+        <p:nvSpPr>
+          <p:cNvPr id="3" name="Text 1"/>
+          <p:cNvSpPr/>
+          <p:nvPr/>
+        </p:nvSpPr>
+        <p:spPr>
+          <a:xfrm>
+            <a:off x="1371600" y="1828800"/>
+            <a:ext cx="6400800" cy="1463040"/>
+          </a:xfrm>
+          <a:prstGeom prst="rect">
+            <a:avLst/>
+          </a:prstGeom>
+          <a:noFill/>
+          <a:ln/>
+        </p:spPr>
+        <p:txBody>
+          <a:bodyPr wrap="square" lIns="0" tIns="0" rIns="0" bIns="0" rtlCol="0" anchor="ctr"/>
+          <a:lstStyle/>
+          <a:p>
+            <a:pPr algn="ctr" indent="0" marL="0">
+              <a:buNone/>
+            </a:pPr>
+            <a:r>
+              <a:rPr lang="en-US" sz="2800" i="1" dirty="0">
+                <a:solidFill>
+                  <a:srgbClr val="00B4D8"/>
+                </a:solidFill>
+                <a:latin typeface="Georgia" pitchFamily="34" charset="0"/>
+                <a:ea typeface="Georgia" pitchFamily="34" charset="-122"/>
+                <a:cs typeface="Georgia" pitchFamily="34" charset="-120"/>
+              </a:rPr>
+              <a:t>Next time: Operator → Orchestrator.</a:t>
+            </a:r>
+            <a:endParaRPr lang="en-US" sz="2800" dirty="0"/>
+          </a:p>
+          <a:p>
+            <a:pPr algn="ctr" indent="0" marL="0">
+              <a:buNone/>
+            </a:pPr>
+            <a:r>
+              <a:rPr lang="en-US" sz="2800" i="1" dirty="0">
+                <a:solidFill>
+                  <a:srgbClr val="00B4D8"/>
+                </a:solidFill>
+                <a:latin typeface="Georgia" pitchFamily="34" charset="0"/>
+                <a:ea typeface="Georgia" pitchFamily="34" charset="-122"/>
+                <a:cs typeface="Georgia" pitchFamily="34" charset="-120"/>
+              </a:rPr>
+              <a:t>We chain agents together.</a:t>
+            </a:r>
+            <a:endParaRPr lang="en-US" sz="2800" dirty="0"/>
+          </a:p>
+          <a:p>
+            <a:pPr algn="ctr" indent="0" marL="0">
+              <a:buNone/>
+            </a:pPr>
+            <a:r>
+              <a:rPr lang="en-US" sz="2800" i="1" dirty="0">
+                <a:solidFill>
+                  <a:srgbClr val="00B4D8"/>
+                </a:solidFill>
+                <a:latin typeface="Georgia" pitchFamily="34" charset="0"/>
+                <a:ea typeface="Georgia" pitchFamily="34" charset="-122"/>
+                <a:cs typeface="Georgia" pitchFamily="34" charset="-120"/>
+              </a:rPr>
+              <a:t>Each one focused. The team does everything.</a:t>
+            </a:r>
+            <a:endParaRPr lang="en-US" sz="2800" dirty="0"/>
           </a:p>
         </p:txBody>
       </p:sp>

</xml_diff>